<commit_message>
Frequency labels: Hz below 1 kHz and k from 1k up on all waterfalls, chart bands in Hz, axis note (report, slides EN/PL)
Co-Authored-By: Claude Sonnet 5.5 <noreply@anthropic.com>
</commit_message>
<xml_diff>
--- a/docs/analysis/chamber-final-2026-10-01/slides/chamber-slides-pl.pptx
+++ b/docs/analysis/chamber-final-2026-10-01/slides/chamber-slides-pl.pptx
@@ -213,16 +213,16 @@
                     <c:v>400–630</c:v>
                   </c:pt>
                   <c:pt idx="2">
-                    <c:v>630–1k</c:v>
+                    <c:v>630–1000</c:v>
                   </c:pt>
                   <c:pt idx="3">
-                    <c:v>1k–1.6k</c:v>
+                    <c:v>1000–1600</c:v>
                   </c:pt>
                   <c:pt idx="4">
-                    <c:v>1.6k–3k</c:v>
+                    <c:v>1600–3000</c:v>
                   </c:pt>
                   <c:pt idx="5">
-                    <c:v>5k–6.4k</c:v>
+                    <c:v>5000–6400</c:v>
                   </c:pt>
                 </c:lvl>
               </c:multiLvlStrCache>
@@ -314,16 +314,16 @@
                     <c:v>400–630</c:v>
                   </c:pt>
                   <c:pt idx="2">
-                    <c:v>630–1k</c:v>
+                    <c:v>630–1000</c:v>
                   </c:pt>
                   <c:pt idx="3">
-                    <c:v>1k–1.6k</c:v>
+                    <c:v>1000–1600</c:v>
                   </c:pt>
                   <c:pt idx="4">
-                    <c:v>1.6k–3k</c:v>
+                    <c:v>1600–3000</c:v>
                   </c:pt>
                   <c:pt idx="5">
-                    <c:v>5k–6.4k</c:v>
+                    <c:v>5000–6400</c:v>
                   </c:pt>
                 </c:lvl>
               </c:multiLvlStrCache>

</xml_diff>

<commit_message>
Slides: say 'motor supply' where the volts are given (EN and PL)
Co-Authored-By: Claude Sonnet 5.5 <noreply@anthropic.com>
</commit_message>
<xml_diff>
--- a/docs/analysis/chamber-final-2026-10-01/slides/chamber-slides-pl.pptx
+++ b/docs/analysis/chamber-final-2026-10-01/slides/chamber-slides-pl.pptx
@@ -11510,7 +11510,7 @@
                 <a:ea typeface="Calibri" pitchFamily="34" charset="-122"/>
                 <a:cs typeface="Calibri" pitchFamily="34" charset="-120"/>
               </a:rPr>
-              <a:t>Czerwony: 31 sierpnia, fabryczne pliki mikrofonów, 7,35 V. Niebieski: 30 września, pliki z poprawkami, 11,7 V.</a:t>
+              <a:t>Czerwony: 31 sierpnia, fabryczne pliki mikrofonów, zasilanie silnika 7,35 V. Niebieski: 30 września, pliki z poprawkami, zasilanie silnika 11,7 V.</a:t>
             </a:r>
             <a:endParaRPr lang="en-US" sz="1600" dirty="0"/>
           </a:p>
@@ -11691,7 +11691,7 @@
                 <a:ea typeface="Calibri" pitchFamily="34" charset="-122"/>
                 <a:cs typeface="Calibri" pitchFamily="34" charset="-120"/>
               </a:rPr>
-              <a:t>20–560 Hz, silnik przy 2000 µs. Oba pomiary miały inne punkty pracy (7,35 V wobec 11,7 V), dlatego niebieski jest niższy.</a:t>
+              <a:t>20–560 Hz, silnik przy 2000 µs. Silnik miał inne napięcie zasilania (7,35 V wobec 11,7 V), dlatego niebieski jest niższy.</a:t>
             </a:r>
             <a:endParaRPr lang="en-US" sz="1100" dirty="0"/>
           </a:p>

</xml_diff>

<commit_message>
Slides and report: the two polars use different propellers; no attribution of the lower level to the supply voltage
Co-Authored-By: Claude Sonnet 5.5 <noreply@anthropic.com>
</commit_message>
<xml_diff>
--- a/docs/analysis/chamber-final-2026-10-01/slides/chamber-slides-pl.pptx
+++ b/docs/analysis/chamber-final-2026-10-01/slides/chamber-slides-pl.pptx
@@ -1448,7 +1448,7 @@
           <a:p>
             <a:r>
               <a:rPr lang="en-US" dirty="0"/>
-              <a:t>Niebieski: pomiar śmigła z 30 września (11,7 V, 7,3 A, ciąg −4 N), odczytany z poprawkami mikrofonów z 16 września. Rozrzut skuteczny wokół średniej 1,45 dB wobec 2,05 dB dla 31 sierpnia; rozstęp 4,0 dB (55,5 do 59,6 dB SPL) wobec 6,7 dB. Niebieski jest o około 11 dB niższy, bo silnik pracował w innym punkcie pracy. Rozstęp 4 dB niebieskiego to trend: głośniej na dole. Uczciwe zastrzeżenie: po zastosowaniu tej samej kalibracji do pomiarów z 1–2 września są one mniej więcej tak samo okrągłe jak z 30 września, więc większość poprawy względem wcześniejszych pomiarów bazowych pochodzi z kalibracji mikrofonów, nie z pomieszczenia.</a:t>
+              <a:t>Niebieski: pomiar śmigła z 30 września (11,7 V, 7,3 A, ciąg −4 N), odczytany z poprawkami mikrofonów z 16 września. Rozrzut skuteczny wokół średniej 1,45 dB wobec 2,05 dB dla 31 sierpnia; rozstęp 4,0 dB (55,5 do 59,6 dB SPL) wobec 6,7 dB. Niebieski jest o około 11 dB niższy, ale nie można tego przypisać napięciu zasilania (niebieski miał wyższe napięcie): pomiary wykonano różnymi śmigłami, a kierunek ciągu był odwrócony, więc poziomów nie wolno porównywać. Rozstęp 4 dB niebieskiego to trend: głośniej na dole. Uczciwe zastrzeżenie: po zastosowaniu tej samej kalibracji do pomiarów z 1–2 września są one mniej więcej tak samo okrągłe jak z 30 września, więc większość poprawy względem wcześniejszych pomiarów bazowych pochodzi z kalibracji mikrofonów, nie z pomieszczenia.</a:t>
             </a:r>
             <a:endParaRPr lang="en-US" dirty="0"/>
           </a:p>
@@ -11510,7 +11510,7 @@
                 <a:ea typeface="Calibri" pitchFamily="34" charset="-122"/>
                 <a:cs typeface="Calibri" pitchFamily="34" charset="-120"/>
               </a:rPr>
-              <a:t>Czerwony: 31 sierpnia, fabryczne pliki mikrofonów, zasilanie silnika 7,35 V. Niebieski: 30 września, pliki z poprawkami, zasilanie silnika 11,7 V.</a:t>
+              <a:t>Czerwony: 31 sierpnia, fabryczne pliki mikrofonów, zasilanie silnika 7,35 V. Niebieski: 30 września, pliki z poprawkami, zasilanie silnika 11,7 V. Dwa różne śmigła.</a:t>
             </a:r>
             <a:endParaRPr lang="en-US" sz="1600" dirty="0"/>
           </a:p>
@@ -11691,7 +11691,7 @@
                 <a:ea typeface="Calibri" pitchFamily="34" charset="-122"/>
                 <a:cs typeface="Calibri" pitchFamily="34" charset="-120"/>
               </a:rPr>
-              <a:t>20–560 Hz, silnik przy 2000 µs. Silnik miał inne napięcie zasilania (7,35 V wobec 11,7 V), dlatego niebieski jest niższy.</a:t>
+              <a:t>20–560 Hz, silnik przy 2000 µs. Różne śmigła i warunki pracy (zasilanie 7,35 V wobec 11,7 V), więc poziomów nie wolno porównywać; porównujemy kształty.</a:t>
             </a:r>
             <a:endParaRPr lang="en-US" sz="1100" dirty="0"/>
           </a:p>

</xml_diff>

<commit_message>
Slides: voltage removed from the comparison slide (EN and PL)
Co-Authored-By: Claude Sonnet 5.5 <noreply@anthropic.com>
</commit_message>
<xml_diff>
--- a/docs/analysis/chamber-final-2026-10-01/slides/chamber-slides-pl.pptx
+++ b/docs/analysis/chamber-final-2026-10-01/slides/chamber-slides-pl.pptx
@@ -11510,7 +11510,7 @@
                 <a:ea typeface="Calibri" pitchFamily="34" charset="-122"/>
                 <a:cs typeface="Calibri" pitchFamily="34" charset="-120"/>
               </a:rPr>
-              <a:t>Czerwony: 31 sierpnia, fabryczne pliki mikrofonów, zasilanie silnika 7,35 V. Niebieski: 30 września, pliki z poprawkami, zasilanie silnika 11,7 V. Dwa różne śmigła.</a:t>
+              <a:t>Czerwony: 31 sierpnia, fabryczne pliki mikrofonów. Niebieski: 30 września, pliki z poprawkami. Dwa różne śmigła.</a:t>
             </a:r>
             <a:endParaRPr lang="en-US" sz="1600" dirty="0"/>
           </a:p>
@@ -11691,7 +11691,7 @@
                 <a:ea typeface="Calibri" pitchFamily="34" charset="-122"/>
                 <a:cs typeface="Calibri" pitchFamily="34" charset="-120"/>
               </a:rPr>
-              <a:t>20–560 Hz, silnik przy 2000 µs. Różne śmigła i warunki pracy (zasilanie 7,35 V wobec 11,7 V), więc poziomów nie wolno porównywać; porównujemy kształty.</a:t>
+              <a:t>20–560 Hz, silnik przy 2000 µs. Różne śmigła i warunki pracy, więc poziomów nie wolno porównywać; porównujemy kształty.</a:t>
             </a:r>
             <a:endParaRPr lang="en-US" sz="1100" dirty="0"/>
           </a:p>

</xml_diff>

<commit_message>
Slides: materials listed from quietest to loudest (EN and PL)
Co-Authored-By: Claude Sonnet 5.5 <noreply@anthropic.com>
</commit_message>
<xml_diff>
--- a/docs/analysis/chamber-final-2026-10-01/slides/chamber-slides-pl.pptx
+++ b/docs/analysis/chamber-final-2026-10-01/slides/chamber-slides-pl.pptx
@@ -12027,11 +12027,11 @@
             <a:avLst/>
           </a:prstGeom>
           <a:solidFill>
-            <a:srgbClr val="2F9E44"/>
+            <a:srgbClr val="7048E8"/>
           </a:solidFill>
           <a:ln w="12700">
             <a:solidFill>
-              <a:srgbClr val="2F9E44"/>
+              <a:srgbClr val="7048E8"/>
             </a:solidFill>
             <a:prstDash val="solid"/>
           </a:ln>
@@ -12070,7 +12070,7 @@
                 <a:ea typeface="Calibri" pitchFamily="34" charset="-122"/>
                 <a:cs typeface="Calibri" pitchFamily="34" charset="-120"/>
               </a:rPr>
-              <a:t>Korek</a:t>
+              <a:t>Filc + guma</a:t>
             </a:r>
             <a:endParaRPr lang="en-US" sz="1800" dirty="0"/>
           </a:p>
@@ -12130,11 +12130,11 @@
             <a:avLst/>
           </a:prstGeom>
           <a:solidFill>
-            <a:srgbClr val="F08C00"/>
+            <a:srgbClr val="2F9E44"/>
           </a:solidFill>
           <a:ln w="12700">
             <a:solidFill>
-              <a:srgbClr val="F08C00"/>
+              <a:srgbClr val="2F9E44"/>
             </a:solidFill>
             <a:prstDash val="solid"/>
           </a:ln>
@@ -12173,7 +12173,7 @@
                 <a:ea typeface="Calibri" pitchFamily="34" charset="-122"/>
                 <a:cs typeface="Calibri" pitchFamily="34" charset="-120"/>
               </a:rPr>
-              <a:t>Guma</a:t>
+              <a:t>Korek</a:t>
             </a:r>
             <a:endParaRPr lang="en-US" sz="1800" dirty="0"/>
           </a:p>
@@ -12212,7 +12212,7 @@
                 <a:ea typeface="Calibri" pitchFamily="34" charset="-122"/>
                 <a:cs typeface="Calibri" pitchFamily="34" charset="-120"/>
               </a:rPr>
-              <a:t>80,6 dB</a:t>
+              <a:t>78,7 dB</a:t>
             </a:r>
             <a:endParaRPr lang="en-US" sz="1800" dirty="0"/>
           </a:p>
@@ -12336,11 +12336,11 @@
             <a:avLst/>
           </a:prstGeom>
           <a:solidFill>
-            <a:srgbClr val="7048E8"/>
+            <a:srgbClr val="F08C00"/>
           </a:solidFill>
           <a:ln w="12700">
             <a:solidFill>
-              <a:srgbClr val="7048E8"/>
+              <a:srgbClr val="F08C00"/>
             </a:solidFill>
             <a:prstDash val="solid"/>
           </a:ln>
@@ -12379,7 +12379,7 @@
                 <a:ea typeface="Calibri" pitchFamily="34" charset="-122"/>
                 <a:cs typeface="Calibri" pitchFamily="34" charset="-120"/>
               </a:rPr>
-              <a:t>Filc + guma</a:t>
+              <a:t>Guma</a:t>
             </a:r>
             <a:endParaRPr lang="en-US" sz="1800" dirty="0"/>
           </a:p>
@@ -12418,7 +12418,7 @@
                 <a:ea typeface="Calibri" pitchFamily="34" charset="-122"/>
                 <a:cs typeface="Calibri" pitchFamily="34" charset="-120"/>
               </a:rPr>
-              <a:t>78,7 dB</a:t>
+              <a:t>80,6 dB</a:t>
             </a:r>
             <a:endParaRPr lang="en-US" sz="1800" dirty="0"/>
           </a:p>

</xml_diff>